<commit_message>
chore: add workspace laws (README, CLAUDE, CONTRIBUTING), IDS report builder, slides, screenshots, docx, pdf
</commit_message>
<xml_diff>
--- a/mayor4code_Defence_Slides.pptx
+++ b/mayor4code_Defence_Slides.pptx
@@ -5,20 +5,20 @@
     <p:sldMasterId id="2147483648" r:id="rId1"/>
   </p:sldMasterIdLst>
   <p:sldIdLst>
-    <p:sldId id="256" r:id="rId2"/>
-    <p:sldId id="257" r:id="rId3"/>
-    <p:sldId id="258" r:id="rId4"/>
-    <p:sldId id="259" r:id="rId5"/>
-    <p:sldId id="260" r:id="rId6"/>
-    <p:sldId id="261" r:id="rId7"/>
-    <p:sldId id="262" r:id="rId8"/>
-    <p:sldId id="263" r:id="rId9"/>
-    <p:sldId id="264" r:id="rId10"/>
-    <p:sldId id="265" r:id="rId11"/>
-    <p:sldId id="266" r:id="rId12"/>
-    <p:sldId id="267" r:id="rId13"/>
+    <p:sldId id="256" r:id="rId7"/>
+    <p:sldId id="257" r:id="rId8"/>
+    <p:sldId id="258" r:id="rId9"/>
+    <p:sldId id="259" r:id="rId10"/>
+    <p:sldId id="260" r:id="rId11"/>
+    <p:sldId id="261" r:id="rId12"/>
+    <p:sldId id="262" r:id="rId13"/>
+    <p:sldId id="263" r:id="rId14"/>
+    <p:sldId id="264" r:id="rId15"/>
+    <p:sldId id="265" r:id="rId16"/>
+    <p:sldId id="266" r:id="rId17"/>
+    <p:sldId id="267" r:id="rId18"/>
   </p:sldIdLst>
-  <p:sldSz cx="12192000" cy="6858000"/>
+  <p:sldSz cx="12191695" cy="6858000" type="screen4x3"/>
   <p:notesSz cx="6858000" cy="9144000"/>
   <p:defaultTextStyle>
     <a:defPPr>
@@ -115,22 +115,6 @@
       </a:defRPr>
     </a:lvl9pPr>
   </p:defaultTextStyle>
-  <p:extLst>
-    <p:ext uri="{EFAFB233-063F-42B5-8137-9DF3F51BA10A}">
-      <p15:sldGuideLst xmlns:p15="http://schemas.microsoft.com/office/powerpoint/2012/main">
-        <p15:guide id="1" orient="horz" pos="2160">
-          <p15:clr>
-            <a:srgbClr val="A4A3A4"/>
-          </p15:clr>
-        </p15:guide>
-        <p15:guide id="2" pos="2880">
-          <p15:clr>
-            <a:srgbClr val="A4A3A4"/>
-          </p15:clr>
-        </p15:guide>
-      </p15:sldGuideLst>
-    </p:ext>
-  </p:extLst>
 </p:presentation>
 </file>
 
@@ -172,9 +156,10 @@
           <a:lstStyle/>
           <a:p>
             <a:r>
-              <a:rPr lang="en-US"/>
+              <a:rPr lang="en-US" smtClean="0"/>
               <a:t>Click to edit Master title style</a:t>
             </a:r>
+            <a:endParaRPr lang="en-US"/>
           </a:p>
         </p:txBody>
       </p:sp>
@@ -290,9 +275,10 @@
           </a:lstStyle>
           <a:p>
             <a:r>
-              <a:rPr lang="en-US"/>
+              <a:rPr lang="en-US" smtClean="0"/>
               <a:t>Click to edit Master subtitle style</a:t>
             </a:r>
+            <a:endParaRPr lang="en-US"/>
           </a:p>
         </p:txBody>
       </p:sp>
@@ -313,7 +299,7 @@
           <a:p>
             <a:fld id="{5BCAD085-E8A6-8845-BD4E-CB4CCA059FC4}" type="datetimeFigureOut">
               <a:rPr lang="en-US" smtClean="0"/>
-              <a:t>7/26/2026</a:t>
+              <a:t>1/27/13</a:t>
             </a:fld>
             <a:endParaRPr lang="en-US"/>
           </a:p>
@@ -407,9 +393,10 @@
           <a:lstStyle/>
           <a:p>
             <a:r>
-              <a:rPr lang="en-US"/>
+              <a:rPr lang="en-US" smtClean="0"/>
               <a:t>Click to edit Master title style</a:t>
             </a:r>
+            <a:endParaRPr lang="en-US"/>
           </a:p>
         </p:txBody>
       </p:sp>
@@ -430,37 +417,38 @@
           <a:p>
             <a:pPr lvl="0"/>
             <a:r>
-              <a:rPr lang="en-US"/>
+              <a:rPr lang="en-US" smtClean="0"/>
               <a:t>Click to edit Master text styles</a:t>
             </a:r>
           </a:p>
           <a:p>
             <a:pPr lvl="1"/>
             <a:r>
-              <a:rPr lang="en-US"/>
+              <a:rPr lang="en-US" smtClean="0"/>
               <a:t>Second level</a:t>
             </a:r>
           </a:p>
           <a:p>
             <a:pPr lvl="2"/>
             <a:r>
-              <a:rPr lang="en-US"/>
+              <a:rPr lang="en-US" smtClean="0"/>
               <a:t>Third level</a:t>
             </a:r>
           </a:p>
           <a:p>
             <a:pPr lvl="3"/>
             <a:r>
-              <a:rPr lang="en-US"/>
+              <a:rPr lang="en-US" smtClean="0"/>
               <a:t>Fourth level</a:t>
             </a:r>
           </a:p>
           <a:p>
             <a:pPr lvl="4"/>
             <a:r>
-              <a:rPr lang="en-US"/>
+              <a:rPr lang="en-US" smtClean="0"/>
               <a:t>Fifth level</a:t>
             </a:r>
+            <a:endParaRPr lang="en-US"/>
           </a:p>
         </p:txBody>
       </p:sp>
@@ -481,7 +469,7 @@
           <a:p>
             <a:fld id="{5BCAD085-E8A6-8845-BD4E-CB4CCA059FC4}" type="datetimeFigureOut">
               <a:rPr lang="en-US" smtClean="0"/>
-              <a:t>7/26/2026</a:t>
+              <a:t>1/27/13</a:t>
             </a:fld>
             <a:endParaRPr lang="en-US"/>
           </a:p>
@@ -580,9 +568,10 @@
           <a:lstStyle/>
           <a:p>
             <a:r>
-              <a:rPr lang="en-US"/>
+              <a:rPr lang="en-US" smtClean="0"/>
               <a:t>Click to edit Master title style</a:t>
             </a:r>
+            <a:endParaRPr lang="en-US"/>
           </a:p>
         </p:txBody>
       </p:sp>
@@ -608,37 +597,38 @@
           <a:p>
             <a:pPr lvl="0"/>
             <a:r>
-              <a:rPr lang="en-US"/>
+              <a:rPr lang="en-US" smtClean="0"/>
               <a:t>Click to edit Master text styles</a:t>
             </a:r>
           </a:p>
           <a:p>
             <a:pPr lvl="1"/>
             <a:r>
-              <a:rPr lang="en-US"/>
+              <a:rPr lang="en-US" smtClean="0"/>
               <a:t>Second level</a:t>
             </a:r>
           </a:p>
           <a:p>
             <a:pPr lvl="2"/>
             <a:r>
-              <a:rPr lang="en-US"/>
+              <a:rPr lang="en-US" smtClean="0"/>
               <a:t>Third level</a:t>
             </a:r>
           </a:p>
           <a:p>
             <a:pPr lvl="3"/>
             <a:r>
-              <a:rPr lang="en-US"/>
+              <a:rPr lang="en-US" smtClean="0"/>
               <a:t>Fourth level</a:t>
             </a:r>
           </a:p>
           <a:p>
             <a:pPr lvl="4"/>
             <a:r>
-              <a:rPr lang="en-US"/>
+              <a:rPr lang="en-US" smtClean="0"/>
               <a:t>Fifth level</a:t>
             </a:r>
+            <a:endParaRPr lang="en-US"/>
           </a:p>
         </p:txBody>
       </p:sp>
@@ -659,7 +649,7 @@
           <a:p>
             <a:fld id="{5BCAD085-E8A6-8845-BD4E-CB4CCA059FC4}" type="datetimeFigureOut">
               <a:rPr lang="en-US" smtClean="0"/>
-              <a:t>7/26/2026</a:t>
+              <a:t>1/27/13</a:t>
             </a:fld>
             <a:endParaRPr lang="en-US"/>
           </a:p>
@@ -753,9 +743,10 @@
           <a:lstStyle/>
           <a:p>
             <a:r>
-              <a:rPr lang="en-US"/>
+              <a:rPr lang="en-US" smtClean="0"/>
               <a:t>Click to edit Master title style</a:t>
             </a:r>
+            <a:endParaRPr lang="en-US"/>
           </a:p>
         </p:txBody>
       </p:sp>
@@ -776,37 +767,38 @@
           <a:p>
             <a:pPr lvl="0"/>
             <a:r>
-              <a:rPr lang="en-US"/>
+              <a:rPr lang="en-US" smtClean="0"/>
               <a:t>Click to edit Master text styles</a:t>
             </a:r>
           </a:p>
           <a:p>
             <a:pPr lvl="1"/>
             <a:r>
-              <a:rPr lang="en-US"/>
+              <a:rPr lang="en-US" smtClean="0"/>
               <a:t>Second level</a:t>
             </a:r>
           </a:p>
           <a:p>
             <a:pPr lvl="2"/>
             <a:r>
-              <a:rPr lang="en-US"/>
+              <a:rPr lang="en-US" smtClean="0"/>
               <a:t>Third level</a:t>
             </a:r>
           </a:p>
           <a:p>
             <a:pPr lvl="3"/>
             <a:r>
-              <a:rPr lang="en-US"/>
+              <a:rPr lang="en-US" smtClean="0"/>
               <a:t>Fourth level</a:t>
             </a:r>
           </a:p>
           <a:p>
             <a:pPr lvl="4"/>
             <a:r>
-              <a:rPr lang="en-US"/>
+              <a:rPr lang="en-US" smtClean="0"/>
               <a:t>Fifth level</a:t>
             </a:r>
+            <a:endParaRPr lang="en-US"/>
           </a:p>
         </p:txBody>
       </p:sp>
@@ -827,7 +819,7 @@
           <a:p>
             <a:fld id="{5BCAD085-E8A6-8845-BD4E-CB4CCA059FC4}" type="datetimeFigureOut">
               <a:rPr lang="en-US" smtClean="0"/>
-              <a:t>7/26/2026</a:t>
+              <a:t>1/27/13</a:t>
             </a:fld>
             <a:endParaRPr lang="en-US"/>
           </a:p>
@@ -930,9 +922,10 @@
           </a:lstStyle>
           <a:p>
             <a:r>
-              <a:rPr lang="en-US"/>
+              <a:rPr lang="en-US" smtClean="0"/>
               <a:t>Click to edit Master title style</a:t>
             </a:r>
+            <a:endParaRPr lang="en-US"/>
           </a:p>
         </p:txBody>
       </p:sp>
@@ -1049,7 +1042,7 @@
           <a:p>
             <a:pPr lvl="0"/>
             <a:r>
-              <a:rPr lang="en-US"/>
+              <a:rPr lang="en-US" smtClean="0"/>
               <a:t>Click to edit Master text styles</a:t>
             </a:r>
           </a:p>
@@ -1072,7 +1065,7 @@
           <a:p>
             <a:fld id="{5BCAD085-E8A6-8845-BD4E-CB4CCA059FC4}" type="datetimeFigureOut">
               <a:rPr lang="en-US" smtClean="0"/>
-              <a:t>7/26/2026</a:t>
+              <a:t>1/27/13</a:t>
             </a:fld>
             <a:endParaRPr lang="en-US"/>
           </a:p>
@@ -1166,9 +1159,10 @@
           <a:lstStyle/>
           <a:p>
             <a:r>
-              <a:rPr lang="en-US"/>
+              <a:rPr lang="en-US" smtClean="0"/>
               <a:t>Click to edit Master title style</a:t>
             </a:r>
+            <a:endParaRPr lang="en-US"/>
           </a:p>
         </p:txBody>
       </p:sp>
@@ -1222,37 +1216,38 @@
           <a:p>
             <a:pPr lvl="0"/>
             <a:r>
-              <a:rPr lang="en-US"/>
+              <a:rPr lang="en-US" smtClean="0"/>
               <a:t>Click to edit Master text styles</a:t>
             </a:r>
           </a:p>
           <a:p>
             <a:pPr lvl="1"/>
             <a:r>
-              <a:rPr lang="en-US"/>
+              <a:rPr lang="en-US" smtClean="0"/>
               <a:t>Second level</a:t>
             </a:r>
           </a:p>
           <a:p>
             <a:pPr lvl="2"/>
             <a:r>
-              <a:rPr lang="en-US"/>
+              <a:rPr lang="en-US" smtClean="0"/>
               <a:t>Third level</a:t>
             </a:r>
           </a:p>
           <a:p>
             <a:pPr lvl="3"/>
             <a:r>
-              <a:rPr lang="en-US"/>
+              <a:rPr lang="en-US" smtClean="0"/>
               <a:t>Fourth level</a:t>
             </a:r>
           </a:p>
           <a:p>
             <a:pPr lvl="4"/>
             <a:r>
-              <a:rPr lang="en-US"/>
+              <a:rPr lang="en-US" smtClean="0"/>
               <a:t>Fifth level</a:t>
             </a:r>
+            <a:endParaRPr lang="en-US"/>
           </a:p>
         </p:txBody>
       </p:sp>
@@ -1306,37 +1301,38 @@
           <a:p>
             <a:pPr lvl="0"/>
             <a:r>
-              <a:rPr lang="en-US"/>
+              <a:rPr lang="en-US" smtClean="0"/>
               <a:t>Click to edit Master text styles</a:t>
             </a:r>
           </a:p>
           <a:p>
             <a:pPr lvl="1"/>
             <a:r>
-              <a:rPr lang="en-US"/>
+              <a:rPr lang="en-US" smtClean="0"/>
               <a:t>Second level</a:t>
             </a:r>
           </a:p>
           <a:p>
             <a:pPr lvl="2"/>
             <a:r>
-              <a:rPr lang="en-US"/>
+              <a:rPr lang="en-US" smtClean="0"/>
               <a:t>Third level</a:t>
             </a:r>
           </a:p>
           <a:p>
             <a:pPr lvl="3"/>
             <a:r>
-              <a:rPr lang="en-US"/>
+              <a:rPr lang="en-US" smtClean="0"/>
               <a:t>Fourth level</a:t>
             </a:r>
           </a:p>
           <a:p>
             <a:pPr lvl="4"/>
             <a:r>
-              <a:rPr lang="en-US"/>
+              <a:rPr lang="en-US" smtClean="0"/>
               <a:t>Fifth level</a:t>
             </a:r>
+            <a:endParaRPr lang="en-US"/>
           </a:p>
         </p:txBody>
       </p:sp>
@@ -1357,7 +1353,7 @@
           <a:p>
             <a:fld id="{5BCAD085-E8A6-8845-BD4E-CB4CCA059FC4}" type="datetimeFigureOut">
               <a:rPr lang="en-US" smtClean="0"/>
-              <a:t>7/26/2026</a:t>
+              <a:t>1/27/13</a:t>
             </a:fld>
             <a:endParaRPr lang="en-US"/>
           </a:p>
@@ -1455,9 +1451,10 @@
           </a:lstStyle>
           <a:p>
             <a:r>
-              <a:rPr lang="en-US"/>
+              <a:rPr lang="en-US" smtClean="0"/>
               <a:t>Click to edit Master title style</a:t>
             </a:r>
+            <a:endParaRPr lang="en-US"/>
           </a:p>
         </p:txBody>
       </p:sp>
@@ -1520,7 +1517,7 @@
           <a:p>
             <a:pPr lvl="0"/>
             <a:r>
-              <a:rPr lang="en-US"/>
+              <a:rPr lang="en-US" smtClean="0"/>
               <a:t>Click to edit Master text styles</a:t>
             </a:r>
           </a:p>
@@ -1576,37 +1573,38 @@
           <a:p>
             <a:pPr lvl="0"/>
             <a:r>
-              <a:rPr lang="en-US"/>
+              <a:rPr lang="en-US" smtClean="0"/>
               <a:t>Click to edit Master text styles</a:t>
             </a:r>
           </a:p>
           <a:p>
             <a:pPr lvl="1"/>
             <a:r>
-              <a:rPr lang="en-US"/>
+              <a:rPr lang="en-US" smtClean="0"/>
               <a:t>Second level</a:t>
             </a:r>
           </a:p>
           <a:p>
             <a:pPr lvl="2"/>
             <a:r>
-              <a:rPr lang="en-US"/>
+              <a:rPr lang="en-US" smtClean="0"/>
               <a:t>Third level</a:t>
             </a:r>
           </a:p>
           <a:p>
             <a:pPr lvl="3"/>
             <a:r>
-              <a:rPr lang="en-US"/>
+              <a:rPr lang="en-US" smtClean="0"/>
               <a:t>Fourth level</a:t>
             </a:r>
           </a:p>
           <a:p>
             <a:pPr lvl="4"/>
             <a:r>
-              <a:rPr lang="en-US"/>
+              <a:rPr lang="en-US" smtClean="0"/>
               <a:t>Fifth level</a:t>
             </a:r>
+            <a:endParaRPr lang="en-US"/>
           </a:p>
         </p:txBody>
       </p:sp>
@@ -1669,7 +1667,7 @@
           <a:p>
             <a:pPr lvl="0"/>
             <a:r>
-              <a:rPr lang="en-US"/>
+              <a:rPr lang="en-US" smtClean="0"/>
               <a:t>Click to edit Master text styles</a:t>
             </a:r>
           </a:p>
@@ -1725,37 +1723,38 @@
           <a:p>
             <a:pPr lvl="0"/>
             <a:r>
-              <a:rPr lang="en-US"/>
+              <a:rPr lang="en-US" smtClean="0"/>
               <a:t>Click to edit Master text styles</a:t>
             </a:r>
           </a:p>
           <a:p>
             <a:pPr lvl="1"/>
             <a:r>
-              <a:rPr lang="en-US"/>
+              <a:rPr lang="en-US" smtClean="0"/>
               <a:t>Second level</a:t>
             </a:r>
           </a:p>
           <a:p>
             <a:pPr lvl="2"/>
             <a:r>
-              <a:rPr lang="en-US"/>
+              <a:rPr lang="en-US" smtClean="0"/>
               <a:t>Third level</a:t>
             </a:r>
           </a:p>
           <a:p>
             <a:pPr lvl="3"/>
             <a:r>
-              <a:rPr lang="en-US"/>
+              <a:rPr lang="en-US" smtClean="0"/>
               <a:t>Fourth level</a:t>
             </a:r>
           </a:p>
           <a:p>
             <a:pPr lvl="4"/>
             <a:r>
-              <a:rPr lang="en-US"/>
+              <a:rPr lang="en-US" smtClean="0"/>
               <a:t>Fifth level</a:t>
             </a:r>
+            <a:endParaRPr lang="en-US"/>
           </a:p>
         </p:txBody>
       </p:sp>
@@ -1776,7 +1775,7 @@
           <a:p>
             <a:fld id="{5BCAD085-E8A6-8845-BD4E-CB4CCA059FC4}" type="datetimeFigureOut">
               <a:rPr lang="en-US" smtClean="0"/>
-              <a:t>7/26/2026</a:t>
+              <a:t>1/27/13</a:t>
             </a:fld>
             <a:endParaRPr lang="en-US"/>
           </a:p>
@@ -1870,9 +1869,10 @@
           <a:lstStyle/>
           <a:p>
             <a:r>
-              <a:rPr lang="en-US"/>
+              <a:rPr lang="en-US" smtClean="0"/>
               <a:t>Click to edit Master title style</a:t>
             </a:r>
+            <a:endParaRPr lang="en-US"/>
           </a:p>
         </p:txBody>
       </p:sp>
@@ -1893,7 +1893,7 @@
           <a:p>
             <a:fld id="{5BCAD085-E8A6-8845-BD4E-CB4CCA059FC4}" type="datetimeFigureOut">
               <a:rPr lang="en-US" smtClean="0"/>
-              <a:t>7/26/2026</a:t>
+              <a:t>1/27/13</a:t>
             </a:fld>
             <a:endParaRPr lang="en-US"/>
           </a:p>
@@ -1988,7 +1988,7 @@
           <a:p>
             <a:fld id="{5BCAD085-E8A6-8845-BD4E-CB4CCA059FC4}" type="datetimeFigureOut">
               <a:rPr lang="en-US" smtClean="0"/>
-              <a:t>7/26/2026</a:t>
+              <a:t>1/27/13</a:t>
             </a:fld>
             <a:endParaRPr lang="en-US"/>
           </a:p>
@@ -2091,9 +2091,10 @@
           </a:lstStyle>
           <a:p>
             <a:r>
-              <a:rPr lang="en-US"/>
+              <a:rPr lang="en-US" smtClean="0"/>
               <a:t>Click to edit Master title style</a:t>
             </a:r>
+            <a:endParaRPr lang="en-US"/>
           </a:p>
         </p:txBody>
       </p:sp>
@@ -2147,37 +2148,38 @@
           <a:p>
             <a:pPr lvl="0"/>
             <a:r>
-              <a:rPr lang="en-US"/>
+              <a:rPr lang="en-US" smtClean="0"/>
               <a:t>Click to edit Master text styles</a:t>
             </a:r>
           </a:p>
           <a:p>
             <a:pPr lvl="1"/>
             <a:r>
-              <a:rPr lang="en-US"/>
+              <a:rPr lang="en-US" smtClean="0"/>
               <a:t>Second level</a:t>
             </a:r>
           </a:p>
           <a:p>
             <a:pPr lvl="2"/>
             <a:r>
-              <a:rPr lang="en-US"/>
+              <a:rPr lang="en-US" smtClean="0"/>
               <a:t>Third level</a:t>
             </a:r>
           </a:p>
           <a:p>
             <a:pPr lvl="3"/>
             <a:r>
-              <a:rPr lang="en-US"/>
+              <a:rPr lang="en-US" smtClean="0"/>
               <a:t>Fourth level</a:t>
             </a:r>
           </a:p>
           <a:p>
             <a:pPr lvl="4"/>
             <a:r>
-              <a:rPr lang="en-US"/>
+              <a:rPr lang="en-US" smtClean="0"/>
               <a:t>Fifth level</a:t>
             </a:r>
+            <a:endParaRPr lang="en-US"/>
           </a:p>
         </p:txBody>
       </p:sp>
@@ -2240,7 +2242,7 @@
           <a:p>
             <a:pPr lvl="0"/>
             <a:r>
-              <a:rPr lang="en-US"/>
+              <a:rPr lang="en-US" smtClean="0"/>
               <a:t>Click to edit Master text styles</a:t>
             </a:r>
           </a:p>
@@ -2263,7 +2265,7 @@
           <a:p>
             <a:fld id="{5BCAD085-E8A6-8845-BD4E-CB4CCA059FC4}" type="datetimeFigureOut">
               <a:rPr lang="en-US" smtClean="0"/>
-              <a:t>7/26/2026</a:t>
+              <a:t>1/27/13</a:t>
             </a:fld>
             <a:endParaRPr lang="en-US"/>
           </a:p>
@@ -2366,9 +2368,10 @@
           </a:lstStyle>
           <a:p>
             <a:r>
-              <a:rPr lang="en-US"/>
+              <a:rPr lang="en-US" smtClean="0"/>
               <a:t>Click to edit Master title style</a:t>
             </a:r>
+            <a:endParaRPr lang="en-US"/>
           </a:p>
         </p:txBody>
       </p:sp>
@@ -2492,7 +2495,7 @@
           <a:p>
             <a:pPr lvl="0"/>
             <a:r>
-              <a:rPr lang="en-US"/>
+              <a:rPr lang="en-US" smtClean="0"/>
               <a:t>Click to edit Master text styles</a:t>
             </a:r>
           </a:p>
@@ -2515,7 +2518,7 @@
           <a:p>
             <a:fld id="{5BCAD085-E8A6-8845-BD4E-CB4CCA059FC4}" type="datetimeFigureOut">
               <a:rPr lang="en-US" smtClean="0"/>
-              <a:t>7/26/2026</a:t>
+              <a:t>1/27/13</a:t>
             </a:fld>
             <a:endParaRPr lang="en-US"/>
           </a:p>
@@ -2624,9 +2627,10 @@
           <a:lstStyle/>
           <a:p>
             <a:r>
-              <a:rPr lang="en-US"/>
+              <a:rPr lang="en-US" smtClean="0"/>
               <a:t>Click to edit Master title style</a:t>
             </a:r>
+            <a:endParaRPr lang="en-US"/>
           </a:p>
         </p:txBody>
       </p:sp>
@@ -2657,37 +2661,38 @@
           <a:p>
             <a:pPr lvl="0"/>
             <a:r>
-              <a:rPr lang="en-US"/>
+              <a:rPr lang="en-US" smtClean="0"/>
               <a:t>Click to edit Master text styles</a:t>
             </a:r>
           </a:p>
           <a:p>
             <a:pPr lvl="1"/>
             <a:r>
-              <a:rPr lang="en-US"/>
+              <a:rPr lang="en-US" smtClean="0"/>
               <a:t>Second level</a:t>
             </a:r>
           </a:p>
           <a:p>
             <a:pPr lvl="2"/>
             <a:r>
-              <a:rPr lang="en-US"/>
+              <a:rPr lang="en-US" smtClean="0"/>
               <a:t>Third level</a:t>
             </a:r>
           </a:p>
           <a:p>
             <a:pPr lvl="3"/>
             <a:r>
-              <a:rPr lang="en-US"/>
+              <a:rPr lang="en-US" smtClean="0"/>
               <a:t>Fourth level</a:t>
             </a:r>
           </a:p>
           <a:p>
             <a:pPr lvl="4"/>
             <a:r>
-              <a:rPr lang="en-US"/>
+              <a:rPr lang="en-US" smtClean="0"/>
               <a:t>Fifth level</a:t>
             </a:r>
+            <a:endParaRPr lang="en-US"/>
           </a:p>
         </p:txBody>
       </p:sp>
@@ -2726,7 +2731,7 @@
           <a:p>
             <a:fld id="{5BCAD085-E8A6-8845-BD4E-CB4CCA059FC4}" type="datetimeFigureOut">
               <a:rPr lang="en-US" smtClean="0"/>
-              <a:t>7/26/2026</a:t>
+              <a:t>1/27/13</a:t>
             </a:fld>
             <a:endParaRPr lang="en-US"/>
           </a:p>
@@ -3085,7 +3090,7 @@
 </file>
 
 <file path=ppt/slides/slide1.xml><?xml version="1.0" encoding="utf-8"?>
-<p:sld xmlns:a="http://schemas.openxmlformats.org/drawingml/2006/main" xmlns:r="http://schemas.openxmlformats.org/officeDocument/2006/relationships" xmlns:p="http://schemas.openxmlformats.org/presentationml/2006/main">
+<p:sld xmlns:a="http://schemas.openxmlformats.org/drawingml/2006/main" xmlns:p="http://schemas.openxmlformats.org/presentationml/2006/main" xmlns:r="http://schemas.openxmlformats.org/officeDocument/2006/relationships">
   <p:cSld>
     <p:bg>
       <p:bgPr>
@@ -3101,14 +3106,7 @@
         <p:cNvGrpSpPr/>
         <p:nvPr/>
       </p:nvGrpSpPr>
-      <p:grpSpPr>
-        <a:xfrm>
-          <a:off x="0" y="0"/>
-          <a:ext cx="0" cy="0"/>
-          <a:chOff x="0" y="0"/>
-          <a:chExt cx="0" cy="0"/>
-        </a:xfrm>
-      </p:grpSpPr>
+      <p:grpSpPr/>
       <p:sp>
         <p:nvSpPr>
           <p:cNvPr id="2" name="Rectangle 1"/>
@@ -3150,7 +3148,6 @@
           <a:lstStyle/>
           <a:p>
             <a:pPr algn="ctr"/>
-            <a:endParaRPr/>
           </a:p>
         </p:txBody>
       </p:sp>
@@ -3195,7 +3192,6 @@
           <a:lstStyle/>
           <a:p>
             <a:pPr algn="ctr"/>
-            <a:endParaRPr/>
           </a:p>
         </p:txBody>
       </p:sp>
@@ -3405,7 +3401,6 @@
           <a:lstStyle/>
           <a:p>
             <a:pPr algn="ctr"/>
-            <a:endParaRPr/>
           </a:p>
         </p:txBody>
       </p:sp>
@@ -3418,7 +3413,7 @@
 </file>
 
 <file path=ppt/slides/slide10.xml><?xml version="1.0" encoding="utf-8"?>
-<p:sld xmlns:a="http://schemas.openxmlformats.org/drawingml/2006/main" xmlns:r="http://schemas.openxmlformats.org/officeDocument/2006/relationships" xmlns:p="http://schemas.openxmlformats.org/presentationml/2006/main">
+<p:sld xmlns:a="http://schemas.openxmlformats.org/drawingml/2006/main" xmlns:p="http://schemas.openxmlformats.org/presentationml/2006/main" xmlns:r="http://schemas.openxmlformats.org/officeDocument/2006/relationships">
   <p:cSld>
     <p:bg>
       <p:bgPr>
@@ -3434,14 +3429,7 @@
         <p:cNvGrpSpPr/>
         <p:nvPr/>
       </p:nvGrpSpPr>
-      <p:grpSpPr>
-        <a:xfrm>
-          <a:off x="0" y="0"/>
-          <a:ext cx="0" cy="0"/>
-          <a:chOff x="0" y="0"/>
-          <a:chExt cx="0" cy="0"/>
-        </a:xfrm>
-      </p:grpSpPr>
+      <p:grpSpPr/>
       <p:sp>
         <p:nvSpPr>
           <p:cNvPr id="2" name="TextBox 1"/>
@@ -3561,7 +3549,6 @@
           <a:lstStyle/>
           <a:p>
             <a:pPr algn="ctr"/>
-            <a:endParaRPr/>
           </a:p>
         </p:txBody>
       </p:sp>
@@ -3677,7 +3664,7 @@
 </file>
 
 <file path=ppt/slides/slide11.xml><?xml version="1.0" encoding="utf-8"?>
-<p:sld xmlns:a="http://schemas.openxmlformats.org/drawingml/2006/main" xmlns:r="http://schemas.openxmlformats.org/officeDocument/2006/relationships" xmlns:p="http://schemas.openxmlformats.org/presentationml/2006/main">
+<p:sld xmlns:a="http://schemas.openxmlformats.org/drawingml/2006/main" xmlns:p="http://schemas.openxmlformats.org/presentationml/2006/main" xmlns:r="http://schemas.openxmlformats.org/officeDocument/2006/relationships">
   <p:cSld>
     <p:bg>
       <p:bgPr>
@@ -3693,14 +3680,7 @@
         <p:cNvGrpSpPr/>
         <p:nvPr/>
       </p:nvGrpSpPr>
-      <p:grpSpPr>
-        <a:xfrm>
-          <a:off x="0" y="0"/>
-          <a:ext cx="0" cy="0"/>
-          <a:chOff x="0" y="0"/>
-          <a:chExt cx="0" cy="0"/>
-        </a:xfrm>
-      </p:grpSpPr>
+      <p:grpSpPr/>
       <p:sp>
         <p:nvSpPr>
           <p:cNvPr id="2" name="TextBox 1"/>
@@ -3820,7 +3800,6 @@
           <a:lstStyle/>
           <a:p>
             <a:pPr algn="ctr"/>
-            <a:endParaRPr/>
           </a:p>
         </p:txBody>
       </p:sp>
@@ -3867,7 +3846,6 @@
           <a:lstStyle/>
           <a:p>
             <a:pPr algn="ctr"/>
-            <a:endParaRPr/>
           </a:p>
         </p:txBody>
       </p:sp>
@@ -3914,7 +3892,6 @@
           <a:lstStyle/>
           <a:p>
             <a:pPr algn="ctr"/>
-            <a:endParaRPr/>
           </a:p>
         </p:txBody>
       </p:sp>
@@ -3985,7 +3962,7 @@
               </a:spcAft>
             </a:pPr>
             <a:r>
-              <a:rPr sz="1500" dirty="0">
+              <a:rPr sz="1500">
                 <a:solidFill>
                   <a:srgbClr val="000000"/>
                 </a:solidFill>
@@ -4001,7 +3978,7 @@
               </a:spcAft>
             </a:pPr>
             <a:r>
-              <a:rPr sz="1500" dirty="0">
+              <a:rPr sz="1500">
                 <a:solidFill>
                   <a:srgbClr val="000000"/>
                 </a:solidFill>
@@ -4059,8 +4036,8 @@
         </p:nvSpPr>
         <p:spPr>
           <a:xfrm>
-            <a:off x="6332220" y="2272025"/>
-            <a:ext cx="5029200" cy="3808735"/>
+            <a:off x="6446520" y="2514600"/>
+            <a:ext cx="4846320" cy="3566160"/>
           </a:xfrm>
           <a:prstGeom prst="rect">
             <a:avLst/>
@@ -4075,11 +4052,11 @@
           <a:p>
             <a:pPr>
               <a:spcAft>
-                <a:spcPts val="300"/>
-              </a:spcAft>
-            </a:pPr>
-            <a:r>
-              <a:rPr lang="en-US" sz="1400" dirty="0">
+                <a:spcPts val="700"/>
+              </a:spcAft>
+            </a:pPr>
+            <a:r>
+              <a:rPr sz="1500">
                 <a:solidFill>
                   <a:srgbClr val="000000"/>
                 </a:solidFill>
@@ -4091,125 +4068,107 @@
           <a:p>
             <a:pPr>
               <a:spcAft>
-                <a:spcPts val="300"/>
-              </a:spcAft>
-            </a:pPr>
-            <a:r>
-              <a:rPr lang="en-US" sz="1400" dirty="0">
+                <a:spcPts val="700"/>
+              </a:spcAft>
+            </a:pPr>
+            <a:r>
+              <a:rPr sz="1500">
                 <a:solidFill>
                   <a:srgbClr val="000000"/>
                 </a:solidFill>
                 <a:latin typeface="Segoe UI"/>
               </a:rPr>
-              <a:t>▸  Deterding, S. et al. (2011). Gamification. Proc. </a:t>
-            </a:r>
-            <a:r>
-              <a:rPr lang="en-US" sz="1400" dirty="0" err="1">
+              <a:t>▸  Deterding, S. et al. (2011). Gamification. Proc. MindTrek, 9–15.</a:t>
+            </a:r>
+          </a:p>
+          <a:p>
+            <a:pPr>
+              <a:spcAft>
+                <a:spcPts val="700"/>
+              </a:spcAft>
+            </a:pPr>
+            <a:r>
+              <a:rPr sz="1500">
                 <a:solidFill>
                   <a:srgbClr val="000000"/>
                 </a:solidFill>
                 <a:latin typeface="Segoe UI"/>
               </a:rPr>
-              <a:t>MindTrek</a:t>
-            </a:r>
-            <a:r>
-              <a:rPr lang="en-US" sz="1400" dirty="0">
+              <a:t>▸  Django Software Foundation. (2024). Django docs. docs.djangoproject.com</a:t>
+            </a:r>
+          </a:p>
+          <a:p>
+            <a:pPr>
+              <a:spcAft>
+                <a:spcPts val="700"/>
+              </a:spcAft>
+            </a:pPr>
+            <a:r>
+              <a:rPr sz="1500">
                 <a:solidFill>
                   <a:srgbClr val="000000"/>
                 </a:solidFill>
                 <a:latin typeface="Segoe UI"/>
               </a:rPr>
-              <a:t>, 9–15.</a:t>
+              <a:t>▸  Duckett, J. (2014). HTML and CSS: Design and build websites. Wiley.</a:t>
             </a:r>
           </a:p>
           <a:p>
             <a:pPr>
               <a:spcAft>
-                <a:spcPts val="300"/>
-              </a:spcAft>
-            </a:pPr>
-            <a:r>
-              <a:rPr lang="en-US" sz="1400" dirty="0">
+                <a:spcPts val="700"/>
+              </a:spcAft>
+            </a:pPr>
+            <a:r>
+              <a:rPr sz="1500">
                 <a:solidFill>
                   <a:srgbClr val="000000"/>
                 </a:solidFill>
                 <a:latin typeface="Segoe UI"/>
               </a:rPr>
-              <a:t>▸  Django Software Foundation. (2024). Django docs. docs.djangoproject.com</a:t>
+              <a:t>▸  Garrison, D. R. (2017). E-learning in the 21st century (3rd ed.). Routledge.</a:t>
             </a:r>
           </a:p>
           <a:p>
             <a:pPr>
               <a:spcAft>
-                <a:spcPts val="300"/>
-              </a:spcAft>
-            </a:pPr>
-            <a:r>
-              <a:rPr lang="en-US" sz="1400" dirty="0">
+                <a:spcPts val="700"/>
+              </a:spcAft>
+            </a:pPr>
+            <a:r>
+              <a:rPr sz="1500">
                 <a:solidFill>
                   <a:srgbClr val="000000"/>
                 </a:solidFill>
                 <a:latin typeface="Segoe UI"/>
               </a:rPr>
-              <a:t>▸  Duckett, J. (2014). HTML and CSS: Design and build websites. Wiley.</a:t>
+              <a:t>▸  Hamari, J. et al. (2014). Does gamification work? HICSS, 3025–3034.</a:t>
             </a:r>
           </a:p>
           <a:p>
             <a:pPr>
               <a:spcAft>
-                <a:spcPts val="300"/>
-              </a:spcAft>
-            </a:pPr>
-            <a:r>
-              <a:rPr lang="en-US" sz="1400" dirty="0">
+                <a:spcPts val="700"/>
+              </a:spcAft>
+            </a:pPr>
+            <a:r>
+              <a:rPr sz="1500">
                 <a:solidFill>
                   <a:srgbClr val="000000"/>
                 </a:solidFill>
                 <a:latin typeface="Segoe UI"/>
               </a:rPr>
-              <a:t>▸  Garrison, D. R. (2017). E-learning in the 21st century (3rd ed.). Routledge.</a:t>
+              <a:t>▸  Pressman, R. S. &amp; Maxim, B. R. (2020). Software engineering (9th ed.). McGraw-Hill.</a:t>
             </a:r>
           </a:p>
           <a:p>
             <a:pPr>
               <a:spcAft>
-                <a:spcPts val="300"/>
-              </a:spcAft>
-            </a:pPr>
-            <a:r>
-              <a:rPr lang="en-US" sz="1400" dirty="0">
-                <a:solidFill>
-                  <a:srgbClr val="000000"/>
-                </a:solidFill>
-                <a:latin typeface="Segoe UI"/>
-              </a:rPr>
-              <a:t>▸  Hamari, J. et al. (2014). Does gamification work? HICSS, 3025–3034.</a:t>
-            </a:r>
-          </a:p>
-          <a:p>
-            <a:pPr>
-              <a:spcAft>
-                <a:spcPts val="300"/>
-              </a:spcAft>
-            </a:pPr>
-            <a:r>
-              <a:rPr lang="en-US" sz="1400" dirty="0">
-                <a:solidFill>
-                  <a:srgbClr val="000000"/>
-                </a:solidFill>
-                <a:latin typeface="Segoe UI"/>
-              </a:rPr>
-              <a:t>▸  Pressman, R. S. &amp; Maxim, B. R. (2020). Software engineering (9th ed.). McGraw-Hill.</a:t>
-            </a:r>
-          </a:p>
-          <a:p>
-            <a:pPr>
-              <a:spcAft>
-                <a:spcPts val="300"/>
-              </a:spcAft>
-            </a:pPr>
-            <a:r>
-              <a:rPr lang="en-US" sz="1400" dirty="0">
+                <a:spcPts val="700"/>
+              </a:spcAft>
+            </a:pPr>
+            <a:r>
+              <a:rPr sz="1500">
                 <a:solidFill>
                   <a:srgbClr val="000000"/>
                 </a:solidFill>
@@ -4229,7 +4188,7 @@
 </file>
 
 <file path=ppt/slides/slide12.xml><?xml version="1.0" encoding="utf-8"?>
-<p:sld xmlns:a="http://schemas.openxmlformats.org/drawingml/2006/main" xmlns:r="http://schemas.openxmlformats.org/officeDocument/2006/relationships" xmlns:p="http://schemas.openxmlformats.org/presentationml/2006/main">
+<p:sld xmlns:a="http://schemas.openxmlformats.org/drawingml/2006/main" xmlns:p="http://schemas.openxmlformats.org/presentationml/2006/main" xmlns:r="http://schemas.openxmlformats.org/officeDocument/2006/relationships">
   <p:cSld>
     <p:bg>
       <p:bgPr>
@@ -4245,14 +4204,7 @@
         <p:cNvGrpSpPr/>
         <p:nvPr/>
       </p:nvGrpSpPr>
-      <p:grpSpPr>
-        <a:xfrm>
-          <a:off x="0" y="0"/>
-          <a:ext cx="0" cy="0"/>
-          <a:chOff x="0" y="0"/>
-          <a:chExt cx="0" cy="0"/>
-        </a:xfrm>
-      </p:grpSpPr>
+      <p:grpSpPr/>
       <p:sp>
         <p:nvSpPr>
           <p:cNvPr id="2" name="Rectangle 1"/>
@@ -4294,7 +4246,6 @@
           <a:lstStyle/>
           <a:p>
             <a:pPr algn="ctr"/>
-            <a:endParaRPr/>
           </a:p>
         </p:txBody>
       </p:sp>
@@ -4417,7 +4368,6 @@
           <a:lstStyle/>
           <a:p>
             <a:pPr algn="ctr"/>
-            <a:endParaRPr/>
           </a:p>
         </p:txBody>
       </p:sp>
@@ -4430,7 +4380,7 @@
 </file>
 
 <file path=ppt/slides/slide2.xml><?xml version="1.0" encoding="utf-8"?>
-<p:sld xmlns:a="http://schemas.openxmlformats.org/drawingml/2006/main" xmlns:r="http://schemas.openxmlformats.org/officeDocument/2006/relationships" xmlns:p="http://schemas.openxmlformats.org/presentationml/2006/main">
+<p:sld xmlns:a="http://schemas.openxmlformats.org/drawingml/2006/main" xmlns:p="http://schemas.openxmlformats.org/presentationml/2006/main" xmlns:r="http://schemas.openxmlformats.org/officeDocument/2006/relationships">
   <p:cSld>
     <p:bg>
       <p:bgPr>
@@ -4446,14 +4396,7 @@
         <p:cNvGrpSpPr/>
         <p:nvPr/>
       </p:nvGrpSpPr>
-      <p:grpSpPr>
-        <a:xfrm>
-          <a:off x="0" y="0"/>
-          <a:ext cx="0" cy="0"/>
-          <a:chOff x="0" y="0"/>
-          <a:chExt cx="0" cy="0"/>
-        </a:xfrm>
-      </p:grpSpPr>
+      <p:grpSpPr/>
       <p:sp>
         <p:nvSpPr>
           <p:cNvPr id="2" name="TextBox 1"/>
@@ -4573,7 +4516,6 @@
           <a:lstStyle/>
           <a:p>
             <a:pPr algn="ctr"/>
-            <a:endParaRPr/>
           </a:p>
         </p:txBody>
       </p:sp>
@@ -4689,7 +4631,7 @@
 </file>
 
 <file path=ppt/slides/slide3.xml><?xml version="1.0" encoding="utf-8"?>
-<p:sld xmlns:a="http://schemas.openxmlformats.org/drawingml/2006/main" xmlns:r="http://schemas.openxmlformats.org/officeDocument/2006/relationships" xmlns:p="http://schemas.openxmlformats.org/presentationml/2006/main">
+<p:sld xmlns:a="http://schemas.openxmlformats.org/drawingml/2006/main" xmlns:p="http://schemas.openxmlformats.org/presentationml/2006/main" xmlns:r="http://schemas.openxmlformats.org/officeDocument/2006/relationships">
   <p:cSld>
     <p:bg>
       <p:bgPr>
@@ -4705,14 +4647,7 @@
         <p:cNvGrpSpPr/>
         <p:nvPr/>
       </p:nvGrpSpPr>
-      <p:grpSpPr>
-        <a:xfrm>
-          <a:off x="0" y="0"/>
-          <a:ext cx="0" cy="0"/>
-          <a:chOff x="0" y="0"/>
-          <a:chExt cx="0" cy="0"/>
-        </a:xfrm>
-      </p:grpSpPr>
+      <p:grpSpPr/>
       <p:sp>
         <p:nvSpPr>
           <p:cNvPr id="2" name="TextBox 1"/>
@@ -4832,7 +4767,6 @@
           <a:lstStyle/>
           <a:p>
             <a:pPr algn="ctr"/>
-            <a:endParaRPr/>
           </a:p>
         </p:txBody>
       </p:sp>
@@ -4948,7 +4882,7 @@
 </file>
 
 <file path=ppt/slides/slide4.xml><?xml version="1.0" encoding="utf-8"?>
-<p:sld xmlns:a="http://schemas.openxmlformats.org/drawingml/2006/main" xmlns:r="http://schemas.openxmlformats.org/officeDocument/2006/relationships" xmlns:p="http://schemas.openxmlformats.org/presentationml/2006/main">
+<p:sld xmlns:a="http://schemas.openxmlformats.org/drawingml/2006/main" xmlns:p="http://schemas.openxmlformats.org/presentationml/2006/main" xmlns:r="http://schemas.openxmlformats.org/officeDocument/2006/relationships">
   <p:cSld>
     <p:bg>
       <p:bgPr>
@@ -4964,14 +4898,7 @@
         <p:cNvGrpSpPr/>
         <p:nvPr/>
       </p:nvGrpSpPr>
-      <p:grpSpPr>
-        <a:xfrm>
-          <a:off x="0" y="0"/>
-          <a:ext cx="0" cy="0"/>
-          <a:chOff x="0" y="0"/>
-          <a:chExt cx="0" cy="0"/>
-        </a:xfrm>
-      </p:grpSpPr>
+      <p:grpSpPr/>
       <p:sp>
         <p:nvSpPr>
           <p:cNvPr id="2" name="TextBox 1"/>
@@ -5091,7 +5018,6 @@
           <a:lstStyle/>
           <a:p>
             <a:pPr algn="ctr"/>
-            <a:endParaRPr/>
           </a:p>
         </p:txBody>
       </p:sp>
@@ -5138,7 +5064,6 @@
           <a:lstStyle/>
           <a:p>
             <a:pPr algn="ctr"/>
-            <a:endParaRPr/>
           </a:p>
         </p:txBody>
       </p:sp>
@@ -5185,7 +5110,6 @@
           <a:lstStyle/>
           <a:p>
             <a:pPr algn="ctr"/>
-            <a:endParaRPr/>
           </a:p>
         </p:txBody>
       </p:sp>
@@ -5434,7 +5358,7 @@
 </file>
 
 <file path=ppt/slides/slide5.xml><?xml version="1.0" encoding="utf-8"?>
-<p:sld xmlns:a="http://schemas.openxmlformats.org/drawingml/2006/main" xmlns:r="http://schemas.openxmlformats.org/officeDocument/2006/relationships" xmlns:p="http://schemas.openxmlformats.org/presentationml/2006/main">
+<p:sld xmlns:a="http://schemas.openxmlformats.org/drawingml/2006/main" xmlns:p="http://schemas.openxmlformats.org/presentationml/2006/main" xmlns:r="http://schemas.openxmlformats.org/officeDocument/2006/relationships">
   <p:cSld>
     <p:bg>
       <p:bgPr>
@@ -5450,14 +5374,7 @@
         <p:cNvGrpSpPr/>
         <p:nvPr/>
       </p:nvGrpSpPr>
-      <p:grpSpPr>
-        <a:xfrm>
-          <a:off x="0" y="0"/>
-          <a:ext cx="0" cy="0"/>
-          <a:chOff x="0" y="0"/>
-          <a:chExt cx="0" cy="0"/>
-        </a:xfrm>
-      </p:grpSpPr>
+      <p:grpSpPr/>
       <p:sp>
         <p:nvSpPr>
           <p:cNvPr id="2" name="TextBox 1"/>
@@ -5577,7 +5494,6 @@
           <a:lstStyle/>
           <a:p>
             <a:pPr algn="ctr"/>
-            <a:endParaRPr/>
           </a:p>
         </p:txBody>
       </p:sp>
@@ -5677,7 +5593,7 @@
 </file>
 
 <file path=ppt/slides/slide6.xml><?xml version="1.0" encoding="utf-8"?>
-<p:sld xmlns:a="http://schemas.openxmlformats.org/drawingml/2006/main" xmlns:r="http://schemas.openxmlformats.org/officeDocument/2006/relationships" xmlns:p="http://schemas.openxmlformats.org/presentationml/2006/main">
+<p:sld xmlns:a="http://schemas.openxmlformats.org/drawingml/2006/main" xmlns:p="http://schemas.openxmlformats.org/presentationml/2006/main" xmlns:r="http://schemas.openxmlformats.org/officeDocument/2006/relationships">
   <p:cSld>
     <p:bg>
       <p:bgPr>
@@ -5693,14 +5609,7 @@
         <p:cNvGrpSpPr/>
         <p:nvPr/>
       </p:nvGrpSpPr>
-      <p:grpSpPr>
-        <a:xfrm>
-          <a:off x="0" y="0"/>
-          <a:ext cx="0" cy="0"/>
-          <a:chOff x="0" y="0"/>
-          <a:chExt cx="0" cy="0"/>
-        </a:xfrm>
-      </p:grpSpPr>
+      <p:grpSpPr/>
       <p:sp>
         <p:nvSpPr>
           <p:cNvPr id="2" name="TextBox 1"/>
@@ -5820,7 +5729,6 @@
           <a:lstStyle/>
           <a:p>
             <a:pPr algn="ctr"/>
-            <a:endParaRPr/>
           </a:p>
         </p:txBody>
       </p:sp>
@@ -5936,7 +5844,7 @@
 </file>
 
 <file path=ppt/slides/slide7.xml><?xml version="1.0" encoding="utf-8"?>
-<p:sld xmlns:a="http://schemas.openxmlformats.org/drawingml/2006/main" xmlns:r="http://schemas.openxmlformats.org/officeDocument/2006/relationships" xmlns:p="http://schemas.openxmlformats.org/presentationml/2006/main">
+<p:sld xmlns:a="http://schemas.openxmlformats.org/drawingml/2006/main" xmlns:p="http://schemas.openxmlformats.org/presentationml/2006/main" xmlns:r="http://schemas.openxmlformats.org/officeDocument/2006/relationships">
   <p:cSld>
     <p:bg>
       <p:bgPr>
@@ -5952,14 +5860,7 @@
         <p:cNvGrpSpPr/>
         <p:nvPr/>
       </p:nvGrpSpPr>
-      <p:grpSpPr>
-        <a:xfrm>
-          <a:off x="0" y="0"/>
-          <a:ext cx="0" cy="0"/>
-          <a:chOff x="0" y="0"/>
-          <a:chExt cx="0" cy="0"/>
-        </a:xfrm>
-      </p:grpSpPr>
+      <p:grpSpPr/>
       <p:sp>
         <p:nvSpPr>
           <p:cNvPr id="2" name="TextBox 1"/>
@@ -6079,7 +5980,6 @@
           <a:lstStyle/>
           <a:p>
             <a:pPr algn="ctr"/>
-            <a:endParaRPr/>
           </a:p>
         </p:txBody>
       </p:sp>
@@ -6126,7 +6026,6 @@
           <a:lstStyle/>
           <a:p>
             <a:pPr algn="ctr"/>
-            <a:endParaRPr/>
           </a:p>
         </p:txBody>
       </p:sp>
@@ -6171,7 +6070,6 @@
           <a:lstStyle/>
           <a:p>
             <a:pPr algn="ctr"/>
-            <a:endParaRPr/>
           </a:p>
         </p:txBody>
       </p:sp>
@@ -6296,7 +6194,6 @@
           <a:lstStyle/>
           <a:p>
             <a:pPr algn="ctr"/>
-            <a:endParaRPr/>
           </a:p>
         </p:txBody>
       </p:sp>
@@ -6341,7 +6238,6 @@
           <a:lstStyle/>
           <a:p>
             <a:pPr algn="ctr"/>
-            <a:endParaRPr/>
           </a:p>
         </p:txBody>
       </p:sp>
@@ -6466,7 +6362,6 @@
           <a:lstStyle/>
           <a:p>
             <a:pPr algn="ctr"/>
-            <a:endParaRPr/>
           </a:p>
         </p:txBody>
       </p:sp>
@@ -6511,7 +6406,6 @@
           <a:lstStyle/>
           <a:p>
             <a:pPr algn="ctr"/>
-            <a:endParaRPr/>
           </a:p>
         </p:txBody>
       </p:sp>
@@ -6636,7 +6530,6 @@
           <a:lstStyle/>
           <a:p>
             <a:pPr algn="ctr"/>
-            <a:endParaRPr/>
           </a:p>
         </p:txBody>
       </p:sp>
@@ -6681,7 +6574,6 @@
           <a:lstStyle/>
           <a:p>
             <a:pPr algn="ctr"/>
-            <a:endParaRPr/>
           </a:p>
         </p:txBody>
       </p:sp>
@@ -6806,7 +6698,6 @@
           <a:lstStyle/>
           <a:p>
             <a:pPr algn="ctr"/>
-            <a:endParaRPr/>
           </a:p>
         </p:txBody>
       </p:sp>
@@ -6851,7 +6742,6 @@
           <a:lstStyle/>
           <a:p>
             <a:pPr algn="ctr"/>
-            <a:endParaRPr/>
           </a:p>
         </p:txBody>
       </p:sp>
@@ -6976,7 +6866,6 @@
           <a:lstStyle/>
           <a:p>
             <a:pPr algn="ctr"/>
-            <a:endParaRPr/>
           </a:p>
         </p:txBody>
       </p:sp>
@@ -7021,7 +6910,6 @@
           <a:lstStyle/>
           <a:p>
             <a:pPr algn="ctr"/>
-            <a:endParaRPr/>
           </a:p>
         </p:txBody>
       </p:sp>
@@ -7112,7 +7000,7 @@
 </file>
 
 <file path=ppt/slides/slide8.xml><?xml version="1.0" encoding="utf-8"?>
-<p:sld xmlns:a="http://schemas.openxmlformats.org/drawingml/2006/main" xmlns:r="http://schemas.openxmlformats.org/officeDocument/2006/relationships" xmlns:p="http://schemas.openxmlformats.org/presentationml/2006/main">
+<p:sld xmlns:a="http://schemas.openxmlformats.org/drawingml/2006/main" xmlns:p="http://schemas.openxmlformats.org/presentationml/2006/main" xmlns:r="http://schemas.openxmlformats.org/officeDocument/2006/relationships">
   <p:cSld>
     <p:bg>
       <p:bgPr>
@@ -7128,14 +7016,7 @@
         <p:cNvGrpSpPr/>
         <p:nvPr/>
       </p:nvGrpSpPr>
-      <p:grpSpPr>
-        <a:xfrm>
-          <a:off x="0" y="0"/>
-          <a:ext cx="0" cy="0"/>
-          <a:chOff x="0" y="0"/>
-          <a:chExt cx="0" cy="0"/>
-        </a:xfrm>
-      </p:grpSpPr>
+      <p:grpSpPr/>
       <p:sp>
         <p:nvSpPr>
           <p:cNvPr id="2" name="TextBox 1"/>
@@ -7255,7 +7136,6 @@
           <a:lstStyle/>
           <a:p>
             <a:pPr algn="ctr"/>
-            <a:endParaRPr/>
           </a:p>
         </p:txBody>
       </p:sp>
@@ -7302,7 +7182,6 @@
           <a:lstStyle/>
           <a:p>
             <a:pPr algn="ctr"/>
-            <a:endParaRPr/>
           </a:p>
         </p:txBody>
       </p:sp>
@@ -7451,7 +7330,6 @@
           <a:lstStyle/>
           <a:p>
             <a:pPr algn="ctr"/>
-            <a:endParaRPr/>
           </a:p>
         </p:txBody>
       </p:sp>
@@ -7566,7 +7444,7 @@
 </file>
 
 <file path=ppt/slides/slide9.xml><?xml version="1.0" encoding="utf-8"?>
-<p:sld xmlns:a="http://schemas.openxmlformats.org/drawingml/2006/main" xmlns:r="http://schemas.openxmlformats.org/officeDocument/2006/relationships" xmlns:p="http://schemas.openxmlformats.org/presentationml/2006/main">
+<p:sld xmlns:a="http://schemas.openxmlformats.org/drawingml/2006/main" xmlns:p="http://schemas.openxmlformats.org/presentationml/2006/main" xmlns:r="http://schemas.openxmlformats.org/officeDocument/2006/relationships">
   <p:cSld>
     <p:bg>
       <p:bgPr>
@@ -7582,14 +7460,7 @@
         <p:cNvGrpSpPr/>
         <p:nvPr/>
       </p:nvGrpSpPr>
-      <p:grpSpPr>
-        <a:xfrm>
-          <a:off x="0" y="0"/>
-          <a:ext cx="0" cy="0"/>
-          <a:chOff x="0" y="0"/>
-          <a:chExt cx="0" cy="0"/>
-        </a:xfrm>
-      </p:grpSpPr>
+      <p:grpSpPr/>
       <p:sp>
         <p:nvSpPr>
           <p:cNvPr id="2" name="TextBox 1"/>
@@ -7709,7 +7580,6 @@
           <a:lstStyle/>
           <a:p>
             <a:pPr algn="ctr"/>
-            <a:endParaRPr/>
           </a:p>
         </p:txBody>
       </p:sp>
@@ -7756,7 +7626,6 @@
           <a:lstStyle/>
           <a:p>
             <a:pPr algn="ctr"/>
-            <a:endParaRPr/>
           </a:p>
         </p:txBody>
       </p:sp>
@@ -7905,7 +7774,6 @@
           <a:lstStyle/>
           <a:p>
             <a:pPr algn="ctr"/>
-            <a:endParaRPr/>
           </a:p>
         </p:txBody>
       </p:sp>

</xml_diff>

<commit_message>
chore: complete mayor4code — fix mockup, all_done stats, expand report to 65pp with flowchart, contributions, enhanced slides
</commit_message>
<xml_diff>
--- a/mayor4code_Defence_Slides.pptx
+++ b/mayor4code_Defence_Slides.pptx
@@ -3503,7 +3503,7 @@
                 </a:solidFill>
                 <a:latin typeface="Segoe UI"/>
               </a:rPr>
-              <a:t>Contributions to Knowledge</a:t>
+              <a:t>System Flowchart: User Journey Through the Platform</a:t>
             </a:r>
           </a:p>
         </p:txBody>
@@ -3554,14 +3554,60 @@
       </p:sp>
       <p:sp>
         <p:nvSpPr>
-          <p:cNvPr id="5" name="TextBox 4"/>
+          <p:cNvPr id="5" name="Rectangle 4"/>
+          <p:cNvSpPr/>
+          <p:nvPr/>
+        </p:nvSpPr>
+        <p:spPr>
+          <a:xfrm>
+            <a:off x="685800" y="1783080"/>
+            <a:ext cx="5257800" cy="4434840"/>
+          </a:xfrm>
+          <a:prstGeom prst="rect">
+            <a:avLst/>
+          </a:prstGeom>
+          <a:solidFill>
+            <a:srgbClr val="F4F4F4"/>
+          </a:solidFill>
+          <a:ln w="12700">
+            <a:solidFill>
+              <a:srgbClr val="000000"/>
+            </a:solidFill>
+          </a:ln>
+          <a:effectLst/>
+        </p:spPr>
+        <p:style>
+          <a:lnRef idx="1">
+            <a:schemeClr val="accent1"/>
+          </a:lnRef>
+          <a:fillRef idx="3">
+            <a:schemeClr val="accent1"/>
+          </a:fillRef>
+          <a:effectRef idx="2">
+            <a:schemeClr val="accent1"/>
+          </a:effectRef>
+          <a:fontRef idx="minor">
+            <a:schemeClr val="lt1"/>
+          </a:fontRef>
+        </p:style>
+        <p:txBody>
+          <a:bodyPr rtlCol="0" anchor="ctr"/>
+          <a:lstStyle/>
+          <a:p>
+            <a:pPr algn="ctr"/>
+          </a:p>
+        </p:txBody>
+      </p:sp>
+      <p:sp>
+        <p:nvSpPr>
+          <p:cNvPr id="6" name="TextBox 5"/>
           <p:cNvSpPr txBox="1"/>
           <p:nvPr/>
         </p:nvSpPr>
         <p:spPr>
           <a:xfrm>
-            <a:off x="685800" y="1737360"/>
-            <a:ext cx="10881360" cy="4754880"/>
+            <a:off x="960120" y="1965960"/>
+            <a:ext cx="4709160" cy="365760"/>
           </a:xfrm>
           <a:prstGeom prst="rect">
             <a:avLst/>
@@ -3569,88 +3615,87 @@
           <a:noFill/>
         </p:spPr>
         <p:txBody>
-          <a:bodyPr wrap="square">
+          <a:bodyPr wrap="square" anchor="t">
             <a:spAutoFit/>
           </a:bodyPr>
           <a:lstStyle/>
           <a:p>
-            <a:pPr>
-              <a:spcAft>
-                <a:spcPts val="1000"/>
-              </a:spcAft>
-            </a:pPr>
-            <a:r>
-              <a:rPr sz="1800">
+            <a:pPr algn="l">
+              <a:spcAft>
+                <a:spcPts val="600"/>
+              </a:spcAft>
+            </a:pPr>
+            <a:r>
+              <a:rPr sz="1500" b="1">
                 <a:solidFill>
                   <a:srgbClr val="000000"/>
                 </a:solidFill>
                 <a:latin typeface="Segoe UI"/>
               </a:rPr>
-              <a:t>▸  An integrated e-learning platform combining structured lessons, a code playground, automated assessment, and gamification in one system.</a:t>
-            </a:r>
-          </a:p>
-          <a:p>
-            <a:pPr>
-              <a:spcAft>
-                <a:spcPts val="1000"/>
-              </a:spcAft>
-            </a:pPr>
-            <a:r>
-              <a:rPr sz="1800">
-                <a:solidFill>
-                  <a:srgbClr val="000000"/>
-                </a:solidFill>
-                <a:latin typeface="Segoe UI"/>
-              </a:rPr>
-              <a:t>▸  A mastery-based locked progression model that enforces understanding of prerequisite concepts before advancement.</a:t>
-            </a:r>
-          </a:p>
-          <a:p>
-            <a:pPr>
-              <a:spcAft>
-                <a:spcPts val="1000"/>
-              </a:spcAft>
-            </a:pPr>
-            <a:r>
-              <a:rPr sz="1800">
-                <a:solidFill>
-                  <a:srgbClr val="000000"/>
-                </a:solidFill>
-                <a:latin typeface="Segoe UI"/>
-              </a:rPr>
-              <a:t>▸  A secure in-browser code execution environment using isolated subprocesses with time limits and operation safeguards.</a:t>
-            </a:r>
-          </a:p>
-          <a:p>
-            <a:pPr>
-              <a:spcAft>
-                <a:spcPts val="1000"/>
-              </a:spcAft>
-            </a:pPr>
-            <a:r>
-              <a:rPr sz="1800">
-                <a:solidFill>
-                  <a:srgbClr val="000000"/>
-                </a:solidFill>
-                <a:latin typeface="Segoe UI"/>
-              </a:rPr>
-              <a:t>▸  An automated certification system with unique verification codes and a gamified leaderboard for learner motivation.</a:t>
-            </a:r>
-          </a:p>
-          <a:p>
-            <a:pPr>
-              <a:spcAft>
-                <a:spcPts val="1000"/>
-              </a:spcAft>
-            </a:pPr>
-            <a:r>
-              <a:rPr sz="1800">
-                <a:solidFill>
-                  <a:srgbClr val="000000"/>
-                </a:solidFill>
-                <a:latin typeface="Segoe UI"/>
-              </a:rPr>
-              <a:t>▸  Demonstration of the Django framework’s capability for building secure and scalable educational web applications.</a:t>
+              <a:t>System Flowchart</a:t>
+            </a:r>
+          </a:p>
+        </p:txBody>
+      </p:sp>
+      <p:pic>
+        <p:nvPicPr>
+          <p:cNvPr id="7" name="Picture 6" descr="flowchart.png"/>
+          <p:cNvPicPr>
+            <a:picLocks noChangeAspect="1"/>
+          </p:cNvPicPr>
+          <p:nvPr/>
+        </p:nvPicPr>
+        <p:blipFill>
+          <a:blip r:embed="rId2"/>
+          <a:stretch>
+            <a:fillRect/>
+          </a:stretch>
+        </p:blipFill>
+        <p:spPr>
+          <a:xfrm>
+            <a:off x="1005840" y="2441448"/>
+            <a:ext cx="4617720" cy="6421517"/>
+          </a:xfrm>
+          <a:prstGeom prst="rect">
+            <a:avLst/>
+          </a:prstGeom>
+        </p:spPr>
+      </p:pic>
+      <p:sp>
+        <p:nvSpPr>
+          <p:cNvPr id="8" name="TextBox 7"/>
+          <p:cNvSpPr txBox="1"/>
+          <p:nvPr/>
+        </p:nvSpPr>
+        <p:spPr>
+          <a:xfrm>
+            <a:off x="960120" y="5852160"/>
+            <a:ext cx="4709160" cy="320040"/>
+          </a:xfrm>
+          <a:prstGeom prst="rect">
+            <a:avLst/>
+          </a:prstGeom>
+          <a:noFill/>
+        </p:spPr>
+        <p:txBody>
+          <a:bodyPr wrap="square" anchor="t">
+            <a:spAutoFit/>
+          </a:bodyPr>
+          <a:lstStyle/>
+          <a:p>
+            <a:pPr algn="ctr">
+              <a:spcAft>
+                <a:spcPts val="600"/>
+              </a:spcAft>
+            </a:pPr>
+            <a:r>
+              <a:rPr sz="1150" b="0">
+                <a:solidFill>
+                  <a:srgbClr val="333333"/>
+                </a:solidFill>
+                <a:latin typeface="Segoe UI"/>
+              </a:rPr>
+              <a:t>Complete user journey from registration to certificate issuance.</a:t>
             </a:r>
           </a:p>
         </p:txBody>
@@ -3754,7 +3799,7 @@
                 </a:solidFill>
                 <a:latin typeface="Segoe UI"/>
               </a:rPr>
-              <a:t>Conclusion / References</a:t>
+              <a:t>Contributions to Knowledge and Conclusion</a:t>
             </a:r>
           </a:p>
         </p:txBody>
@@ -3929,7 +3974,7 @@
                 </a:solidFill>
                 <a:latin typeface="Segoe UI"/>
               </a:rPr>
-              <a:t>Conclusion</a:t>
+              <a:t>Contributions</a:t>
             </a:r>
           </a:p>
         </p:txBody>
@@ -3968,7 +4013,7 @@
                 </a:solidFill>
                 <a:latin typeface="Segoe UI"/>
               </a:rPr>
-              <a:t>▸  All objectives were achieved: structured lessons with locked progression, secure authentication, an interactive playground, automated quiz scoring, progress tracking, certification, and a leaderboard were implemented and verified through testing.</a:t>
+              <a:t>▸  Integrated platform combining structured lessons, playground, assessment, certification, and gamification in one free system.</a:t>
             </a:r>
           </a:p>
           <a:p>
@@ -3984,7 +4029,55 @@
                 </a:solidFill>
                 <a:latin typeface="Segoe UI"/>
               </a:rPr>
-              <a:t>▸  The platform provides a practical solution to key challenges in introductory programming education.</a:t>
+              <a:t>▸  Mastery-based locked progression enforcing prerequisite understanding.</a:t>
+            </a:r>
+          </a:p>
+          <a:p>
+            <a:pPr>
+              <a:spcAft>
+                <a:spcPts val="700"/>
+              </a:spcAft>
+            </a:pPr>
+            <a:r>
+              <a:rPr sz="1500">
+                <a:solidFill>
+                  <a:srgbClr val="000000"/>
+                </a:solidFill>
+                <a:latin typeface="Segoe UI"/>
+              </a:rPr>
+              <a:t>▸  Secure in-browser code execution via isolated subprocesses.</a:t>
+            </a:r>
+          </a:p>
+          <a:p>
+            <a:pPr>
+              <a:spcAft>
+                <a:spcPts val="700"/>
+              </a:spcAft>
+            </a:pPr>
+            <a:r>
+              <a:rPr sz="1500">
+                <a:solidFill>
+                  <a:srgbClr val="000000"/>
+                </a:solidFill>
+                <a:latin typeface="Segoe UI"/>
+              </a:rPr>
+              <a:t>▸  Automated certification with unique verification codes.</a:t>
+            </a:r>
+          </a:p>
+          <a:p>
+            <a:pPr>
+              <a:spcAft>
+                <a:spcPts val="700"/>
+              </a:spcAft>
+            </a:pPr>
+            <a:r>
+              <a:rPr sz="1500">
+                <a:solidFill>
+                  <a:srgbClr val="000000"/>
+                </a:solidFill>
+                <a:latin typeface="Segoe UI"/>
+              </a:rPr>
+              <a:t>▸  Reference implementation of Django for educational web apps.</a:t>
             </a:r>
           </a:p>
         </p:txBody>
@@ -4023,7 +4116,7 @@
                 </a:solidFill>
                 <a:latin typeface="Segoe UI"/>
               </a:rPr>
-              <a:t>References</a:t>
+              <a:t>Conclusion / Recommendations</a:t>
             </a:r>
           </a:p>
         </p:txBody>
@@ -4062,7 +4155,7 @@
                 </a:solidFill>
                 <a:latin typeface="Segoe UI"/>
               </a:rPr>
-              <a:t>▸  Anderson, T. (2008). The theory and practice of online learning (2nd ed.). Athabasca University Press.</a:t>
+              <a:t>▸  All objectives were achieved: structured lessons with locked progression, secure authentication, interactive playground, automated quiz scoring, progress tracking, certification, and a leaderboard were implemented and verified through testing.</a:t>
             </a:r>
           </a:p>
           <a:p>
@@ -4078,103 +4171,7 @@
                 </a:solidFill>
                 <a:latin typeface="Segoe UI"/>
               </a:rPr>
-              <a:t>▸  Deterding, S. et al. (2011). Gamification. Proc. MindTrek, 9–15.</a:t>
-            </a:r>
-          </a:p>
-          <a:p>
-            <a:pPr>
-              <a:spcAft>
-                <a:spcPts val="700"/>
-              </a:spcAft>
-            </a:pPr>
-            <a:r>
-              <a:rPr sz="1500">
-                <a:solidFill>
-                  <a:srgbClr val="000000"/>
-                </a:solidFill>
-                <a:latin typeface="Segoe UI"/>
-              </a:rPr>
-              <a:t>▸  Django Software Foundation. (2024). Django docs. docs.djangoproject.com</a:t>
-            </a:r>
-          </a:p>
-          <a:p>
-            <a:pPr>
-              <a:spcAft>
-                <a:spcPts val="700"/>
-              </a:spcAft>
-            </a:pPr>
-            <a:r>
-              <a:rPr sz="1500">
-                <a:solidFill>
-                  <a:srgbClr val="000000"/>
-                </a:solidFill>
-                <a:latin typeface="Segoe UI"/>
-              </a:rPr>
-              <a:t>▸  Duckett, J. (2014). HTML and CSS: Design and build websites. Wiley.</a:t>
-            </a:r>
-          </a:p>
-          <a:p>
-            <a:pPr>
-              <a:spcAft>
-                <a:spcPts val="700"/>
-              </a:spcAft>
-            </a:pPr>
-            <a:r>
-              <a:rPr sz="1500">
-                <a:solidFill>
-                  <a:srgbClr val="000000"/>
-                </a:solidFill>
-                <a:latin typeface="Segoe UI"/>
-              </a:rPr>
-              <a:t>▸  Garrison, D. R. (2017). E-learning in the 21st century (3rd ed.). Routledge.</a:t>
-            </a:r>
-          </a:p>
-          <a:p>
-            <a:pPr>
-              <a:spcAft>
-                <a:spcPts val="700"/>
-              </a:spcAft>
-            </a:pPr>
-            <a:r>
-              <a:rPr sz="1500">
-                <a:solidFill>
-                  <a:srgbClr val="000000"/>
-                </a:solidFill>
-                <a:latin typeface="Segoe UI"/>
-              </a:rPr>
-              <a:t>▸  Hamari, J. et al. (2014). Does gamification work? HICSS, 3025–3034.</a:t>
-            </a:r>
-          </a:p>
-          <a:p>
-            <a:pPr>
-              <a:spcAft>
-                <a:spcPts val="700"/>
-              </a:spcAft>
-            </a:pPr>
-            <a:r>
-              <a:rPr sz="1500">
-                <a:solidFill>
-                  <a:srgbClr val="000000"/>
-                </a:solidFill>
-                <a:latin typeface="Segoe UI"/>
-              </a:rPr>
-              <a:t>▸  Pressman, R. S. &amp; Maxim, B. R. (2020). Software engineering (9th ed.). McGraw-Hill.</a:t>
-            </a:r>
-          </a:p>
-          <a:p>
-            <a:pPr>
-              <a:spcAft>
-                <a:spcPts val="700"/>
-              </a:spcAft>
-            </a:pPr>
-            <a:r>
-              <a:rPr sz="1500">
-                <a:solidFill>
-                  <a:srgbClr val="000000"/>
-                </a:solidFill>
-                <a:latin typeface="Segoe UI"/>
-              </a:rPr>
-              <a:t>▸  Sommerville, I. (2016). Software engineering (10th ed.). Pearson.</a:t>
+              <a:t>▸  Recommendations include adopting the platform for introductory programming, extending with more courses, and adding adaptive learning features.</a:t>
             </a:r>
           </a:p>
         </p:txBody>
@@ -4470,7 +4467,7 @@
                 </a:solidFill>
                 <a:latin typeface="Segoe UI"/>
               </a:rPr>
-              <a:t>Introduction</a:t>
+              <a:t>Introduction to the mayor4code E-Learning Platform</a:t>
             </a:r>
           </a:p>
         </p:txBody>
@@ -4721,7 +4718,7 @@
                 </a:solidFill>
                 <a:latin typeface="Segoe UI"/>
               </a:rPr>
-              <a:t>Motivation / Statement of the Problem</a:t>
+              <a:t>Motivation and Problem Statement: Challenges in Programming Education</a:t>
             </a:r>
           </a:p>
         </p:txBody>
@@ -5448,7 +5445,7 @@
                 </a:solidFill>
                 <a:latin typeface="Segoe UI"/>
               </a:rPr>
-              <a:t>Significance of the Study</a:t>
+              <a:t>Significance of the Study: Educational, Technological, and Economic Impact</a:t>
             </a:r>
           </a:p>
         </p:txBody>
@@ -5683,7 +5680,7 @@
                 </a:solidFill>
                 <a:latin typeface="Segoe UI"/>
               </a:rPr>
-              <a:t>Literature Review</a:t>
+              <a:t>Literature Review: E-Learning, Gamification, and Related Platforms</a:t>
             </a:r>
           </a:p>
         </p:txBody>
@@ -5782,7 +5779,7 @@
                 </a:solidFill>
                 <a:latin typeface="Segoe UI"/>
               </a:rPr>
-              <a:t>▸  Interactive coding platforms with instant feedback significantly improve programming education outcomes (Pressman &amp; Maxim, 2020).</a:t>
+              <a:t>▸  Constructivist theory (Piaget, 1952; Vygotsky, 1978) supports interactive, scaffolded learning environments like mayor4code.</a:t>
             </a:r>
           </a:p>
           <a:p>
@@ -5798,23 +5795,23 @@
                 </a:solidFill>
                 <a:latin typeface="Segoe UI"/>
               </a:rPr>
+              <a:t>▸  Mastery learning (Bloom, 1968; Guskey, 2007) validates the locked-progression model that enforces prerequisite understanding.</a:t>
+            </a:r>
+          </a:p>
+          <a:p>
+            <a:pPr>
+              <a:spcAft>
+                <a:spcPts val="1000"/>
+              </a:spcAft>
+            </a:pPr>
+            <a:r>
+              <a:rPr sz="1800">
+                <a:solidFill>
+                  <a:srgbClr val="000000"/>
+                </a:solidFill>
+                <a:latin typeface="Segoe UI"/>
+              </a:rPr>
               <a:t>▸  Gamification through certificates and leaderboards boosts learner engagement and motivation (Deterding et al., 2011; Hamari et al., 2014).</a:t>
-            </a:r>
-          </a:p>
-          <a:p>
-            <a:pPr>
-              <a:spcAft>
-                <a:spcPts val="1000"/>
-              </a:spcAft>
-            </a:pPr>
-            <a:r>
-              <a:rPr sz="1800">
-                <a:solidFill>
-                  <a:srgbClr val="000000"/>
-                </a:solidFill>
-                <a:latin typeface="Segoe UI"/>
-              </a:rPr>
-              <a:t>▸  The Django framework provides rapid development with built-in security and an object-relational mapper (Django Software Foundation, 2024).</a:t>
             </a:r>
           </a:p>
           <a:p>
@@ -5934,7 +5931,7 @@
                 </a:solidFill>
                 <a:latin typeface="Segoe UI"/>
               </a:rPr>
-              <a:t>Methodology</a:t>
+              <a:t>Methodology: Agile Approach, Three-Tier Architecture, and System Flowchart</a:t>
             </a:r>
           </a:p>
         </p:txBody>
@@ -6947,7 +6944,7 @@
                 </a:solidFill>
                 <a:latin typeface="Segoe UI"/>
               </a:rPr>
-              <a:t>Modules</a:t>
+              <a:t>Flowchart</a:t>
             </a:r>
           </a:p>
         </p:txBody>
@@ -6986,7 +6983,7 @@
                 </a:solidFill>
                 <a:latin typeface="Segoe UI"/>
               </a:rPr>
-              <a:t>Auth, Lessons, Quizzes, Playground, Certificates, Leaderboard.</a:t>
+              <a:t>See Slide 10 for the complete system flowchart.</a:t>
             </a:r>
           </a:p>
         </p:txBody>
@@ -7090,7 +7087,7 @@
                 </a:solidFill>
                 <a:latin typeface="Segoe UI"/>
               </a:rPr>
-              <a:t>Implementation</a:t>
+              <a:t>Implementation: System Interfaces (Screenshots)</a:t>
             </a:r>
           </a:p>
         </p:txBody>
@@ -7534,7 +7531,7 @@
                 </a:solidFill>
                 <a:latin typeface="Segoe UI"/>
               </a:rPr>
-              <a:t>Results &amp; Discussion</a:t>
+              <a:t>Results and Discussion: Testing Results and Performance Evaluation</a:t>
             </a:r>
           </a:p>
         </p:txBody>

</xml_diff>